<commit_message>
Organise ArogyaAegis into three phases
- phase-1/ (completed): AD8232 ECG firmware for the ESP32-S3 (R-peak
  heart rate, DANGER alert + vibration, OLED), Wi-Fi and Bluetooth
  dashboards, wiring diagrams, ECG beat model and training code.
- phase-2/: plan for multi-sensor stress sensing and biofeedback (GSR,
  PPG/SpO2, motion, breathing, battery, microSD; HRV, stress model,
  paced-breathing haptics).
- phase-3/: plan for the heat, air-quality and SOS layer (skin/air
  temperature, PM2.5, GPS, SMS SOS, v2 power; heat, dehydration, AF,
  fall and respiratory models; app; pilot).
- README: roadmap and repo layout. docs/index.html: Phase column in the
  pin map. docs/app/: Bluetooth dashboard served by GitHub Pages.
- SIH deck: wording updated on slides 2 and 3.
</commit_message>
<xml_diff>
--- a/assets/ArogyaAegis_SIH26181.pptx
+++ b/assets/ArogyaAegis_SIH26181.pptx
@@ -3810,7 +3810,7 @@
                 </a:solidFill>
                 <a:latin typeface="Calibri"/>
               </a:rPr>
-              <a:t> is a smart vest (SereniSuit v2) with 9 body and environment sensors and an ESP32-S3 running </a:t>
+              <a:t> is a smart vest with 9 body and environment sensors and an ESP32-S3 running </a:t>
             </a:r>
             <a:r>
               <a:rPr sz="1080" b="1" i="0">
@@ -5608,7 +5608,7 @@
                 </a:solidFill>
                 <a:latin typeface="Calibri"/>
               </a:rPr>
-              <a:t>1D-CNN on GSR + PPG + IMU windows (existing SereniSuit model).</a:t>
+              <a:t>1D-CNN on GSR + PPG + IMU windows (our existing stress model).</a:t>
             </a:r>
           </a:p>
           <a:p>

</xml_diff>